<commit_message>
Slides: sd-13-023 answer table at 34 px
Co-Authored-By: Claude Opus 5.5 <noreply@anthropic.com>
Claude-Session: https://claude.ai/code/session_01TQmrJYLm4GPgtXpQaEk7ey
</commit_message>
<xml_diff>
--- a/system-design-101/vi/lessons/sd-13-023/slides/sd-13-023.pptx
+++ b/system-design-101/vi/lessons/sd-13-023/slides/sd-13-023.pptx
@@ -7906,12 +7906,12 @@
                     <a:p>
                       <a:pPr algn="l" indent="0" marL="0">
                         <a:lnSpc>
-                          <a:spcPts val="2880"/>
+                          <a:spcPts val="3060"/>
                         </a:lnSpc>
                         <a:buNone/>
                       </a:pPr>
                       <a:r>
-                        <a:rPr lang="en-US" sz="2400" b="1" dirty="0" spc="-16" kern="0">
+                        <a:rPr lang="en-US" sz="2550" b="1" dirty="0" spc="-16" kern="0">
                           <a:solidFill>
                             <a:srgbClr val="14161C"/>
                           </a:solidFill>
@@ -7922,7 +7922,7 @@
                         <a:t>Trường</a:t>
                       </a:r>
                       <a:r>
-                        <a:rPr lang="en-US" sz="2400" b="1" dirty="0" spc="-2" kern="0">
+                        <a:rPr lang="en-US" sz="2550" b="1" dirty="0" spc="-2" kern="0">
                           <a:solidFill>
                             <a:srgbClr val="14161C"/>
                           </a:solidFill>
@@ -7933,7 +7933,7 @@
                         <a:t> hợp</a:t>
                       </a:r>
                       <a:r>
-                        <a:rPr lang="en-US" sz="2400" b="1" dirty="0" spc="-5" kern="0">
+                        <a:rPr lang="en-US" sz="2550" b="1" dirty="0" spc="-3" kern="0">
                           <a:solidFill>
                             <a:srgbClr val="14161C"/>
                           </a:solidFill>
@@ -7944,7 +7944,7 @@
                         <a:t> (theo</a:t>
                       </a:r>
                       <a:r>
-                        <a:rPr lang="en-US" sz="2400" b="1" dirty="0" spc="-1" kern="0">
+                        <a:rPr lang="en-US" sz="2550" b="1" dirty="0" spc="0" kern="0">
                           <a:solidFill>
                             <a:srgbClr val="14161C"/>
                           </a:solidFill>
@@ -7952,21 +7952,10 @@
                           <a:ea typeface="Be Vietnam Pro" pitchFamily="34" charset="-122"/>
                           <a:cs typeface="Be Vietnam Pro" pitchFamily="34" charset="-120"/>
                         </a:rPr>
-                        <a:t> tài</a:t>
+                        <a:t> tài liệu</a:t>
                       </a:r>
                       <a:r>
-                        <a:rPr lang="en-US" sz="2400" b="1" dirty="0" spc="0" kern="0">
-                          <a:solidFill>
-                            <a:srgbClr val="14161C"/>
-                          </a:solidFill>
-                          <a:latin typeface="Be Vietnam Pro" pitchFamily="34" charset="0"/>
-                          <a:ea typeface="Be Vietnam Pro" pitchFamily="34" charset="-122"/>
-                          <a:cs typeface="Be Vietnam Pro" pitchFamily="34" charset="-120"/>
-                        </a:rPr>
-                        <a:t> liệu</a:t>
-                      </a:r>
-                      <a:r>
-                        <a:rPr lang="en-US" sz="2400" b="1" dirty="0" spc="-8" kern="0">
+                        <a:rPr lang="en-US" sz="2550" b="1" dirty="0" spc="-9" kern="0">
                           <a:solidFill>
                             <a:srgbClr val="14161C"/>
                           </a:solidFill>
@@ -7979,7 +7968,7 @@
                       <a:endParaRPr lang="en-US" sz="1200" dirty="0"/>
                     </a:p>
                   </a:txBody>
-                  <a:tcPr marL="266700" marR="266700" marT="266700" marB="266700" anchor="ctr">
+                  <a:tcPr marL="228600" marR="228600" marT="228600" marB="228600" anchor="ctr">
                     <a:lnL w="0" cap="flat" cmpd="sng" algn="ctr">
                       <a:noFill/>
                     </a:lnL>
@@ -8004,12 +7993,12 @@
                     <a:p>
                       <a:pPr algn="l" indent="0" marL="0">
                         <a:lnSpc>
-                          <a:spcPts val="2880"/>
+                          <a:spcPts val="3060"/>
                         </a:lnSpc>
                         <a:buNone/>
                       </a:pPr>
                       <a:r>
-                        <a:rPr lang="en-US" sz="2400" b="1" dirty="0" spc="-3" kern="0">
+                        <a:rPr lang="en-US" sz="2550" b="1" dirty="0" spc="2" kern="0">
                           <a:solidFill>
                             <a:srgbClr val="14161C"/>
                           </a:solidFill>
@@ -8020,7 +8009,7 @@
                         <a:t>Ai</a:t>
                       </a:r>
                       <a:r>
-                        <a:rPr lang="en-US" sz="2400" b="1" dirty="0" spc="0" kern="0">
+                        <a:rPr lang="en-US" sz="2550" b="1" dirty="0" spc="0" kern="0">
                           <a:solidFill>
                             <a:srgbClr val="14161C"/>
                           </a:solidFill>
@@ -8031,7 +8020,7 @@
                         <a:t> cập</a:t>
                       </a:r>
                       <a:r>
-                        <a:rPr lang="en-US" sz="2400" b="1" dirty="0" spc="-7" kern="0">
+                        <a:rPr lang="en-US" sz="2550" b="1" dirty="0" spc="-6" kern="0">
                           <a:solidFill>
                             <a:srgbClr val="14161C"/>
                           </a:solidFill>
@@ -8044,7 +8033,7 @@
                       <a:endParaRPr lang="en-US" sz="1200" dirty="0"/>
                     </a:p>
                   </a:txBody>
-                  <a:tcPr marL="266700" marR="266700" marT="266700" marB="266700" anchor="ctr">
+                  <a:tcPr marL="228600" marR="228600" marT="228600" marB="228600" anchor="ctr">
                     <a:lnL w="19050" cap="flat" cmpd="sng" algn="ctr">
                       <a:solidFill>
                         <a:srgbClr val="DDD5C1"/>
@@ -8077,12 +8066,12 @@
                     <a:p>
                       <a:pPr algn="l" indent="0" marL="0">
                         <a:lnSpc>
-                          <a:spcPts val="2880"/>
+                          <a:spcPts val="3060"/>
                         </a:lnSpc>
                         <a:buNone/>
                       </a:pPr>
                       <a:r>
-                        <a:rPr lang="en-US" sz="2400" dirty="0" spc="-10" kern="0">
+                        <a:rPr lang="en-US" sz="2550" dirty="0" spc="-11" kern="0">
                           <a:solidFill>
                             <a:srgbClr val="14161C"/>
                           </a:solidFill>
@@ -8093,7 +8082,7 @@
                         <a:t>Container</a:t>
                       </a:r>
                       <a:r>
-                        <a:rPr lang="en-US" sz="2400" dirty="0" spc="-6" kern="0">
+                        <a:rPr lang="en-US" sz="2550" dirty="0" spc="-8" kern="0">
                           <a:solidFill>
                             <a:srgbClr val="14161C"/>
                           </a:solidFill>
@@ -8104,7 +8093,7 @@
                         <a:t> image</a:t>
                       </a:r>
                       <a:r>
-                        <a:rPr lang="en-US" sz="2400" dirty="0" spc="-1" kern="0">
+                        <a:rPr lang="en-US" sz="2550" dirty="0" spc="-2" kern="0">
                           <a:solidFill>
                             <a:srgbClr val="14161C"/>
                           </a:solidFill>
@@ -8115,7 +8104,7 @@
                         <a:t> hoặc</a:t>
                       </a:r>
                       <a:r>
-                        <a:rPr lang="en-US" sz="2400" dirty="0" spc="-5" kern="0">
+                        <a:rPr lang="en-US" sz="2550" dirty="0" spc="-5" kern="0">
                           <a:solidFill>
                             <a:srgbClr val="14161C"/>
                           </a:solidFill>
@@ -8126,7 +8115,7 @@
                         <a:t> runtime</a:t>
                       </a:r>
                       <a:r>
-                        <a:rPr lang="en-US" sz="2400" dirty="0" spc="2" kern="0">
+                        <a:rPr lang="en-US" sz="2550" dirty="0" spc="-2" kern="0">
                           <a:solidFill>
                             <a:srgbClr val="14161C"/>
                           </a:solidFill>
@@ -8137,7 +8126,7 @@
                         <a:t> tự</a:t>
                       </a:r>
                       <a:r>
-                        <a:rPr lang="en-US" sz="2400" dirty="0" spc="23" kern="0">
+                        <a:rPr lang="en-US" sz="2550" dirty="0" spc="19" kern="0">
                           <a:solidFill>
                             <a:srgbClr val="14161C"/>
                           </a:solidFill>
@@ -8150,7 +8139,7 @@
                       <a:endParaRPr lang="en-US" sz="1200" dirty="0"/>
                     </a:p>
                   </a:txBody>
-                  <a:tcPr marL="266700" marR="266700" marT="266700" marB="266700" anchor="ctr">
+                  <a:tcPr marL="228600" marR="228600" marT="228600" marB="228600" anchor="ctr">
                     <a:lnL w="0" cap="flat" cmpd="sng" algn="ctr">
                       <a:noFill/>
                     </a:lnL>
@@ -8181,12 +8170,12 @@
                     <a:p>
                       <a:pPr algn="l" indent="0" marL="0">
                         <a:lnSpc>
-                          <a:spcPts val="2880"/>
+                          <a:spcPts val="3060"/>
                         </a:lnSpc>
                         <a:buNone/>
                       </a:pPr>
                       <a:r>
-                        <a:rPr lang="en-US" sz="2400" dirty="0" kern="0">
+                        <a:rPr lang="en-US" sz="2550" dirty="0" spc="1" kern="0">
                           <a:solidFill>
                             <a:srgbClr val="14161C"/>
                           </a:solidFill>
@@ -8194,12 +8183,23 @@
                           <a:ea typeface="Be Vietnam Pro" pitchFamily="34" charset="-122"/>
                           <a:cs typeface="Be Vietnam Pro" pitchFamily="34" charset="-120"/>
                         </a:rPr>
-                        <a:t>Nhóm bạn</a:t>
+                        <a:t>Nhóm</a:t>
+                      </a:r>
+                      <a:r>
+                        <a:rPr lang="en-US" sz="2550" dirty="0" spc="-3" kern="0">
+                          <a:solidFill>
+                            <a:srgbClr val="14161C"/>
+                          </a:solidFill>
+                          <a:latin typeface="Be Vietnam Pro" pitchFamily="34" charset="0"/>
+                          <a:ea typeface="Be Vietnam Pro" pitchFamily="34" charset="-122"/>
+                          <a:cs typeface="Be Vietnam Pro" pitchFamily="34" charset="-120"/>
+                        </a:rPr>
+                        <a:t> bạn</a:t>
                       </a:r>
                       <a:endParaRPr lang="en-US" sz="1200" dirty="0"/>
                     </a:p>
                   </a:txBody>
-                  <a:tcPr marL="266700" marR="266700" marT="266700" marB="266700" anchor="ctr">
+                  <a:tcPr marL="228600" marR="228600" marT="228600" marB="228600" anchor="ctr">
                     <a:lnL w="19050" cap="flat" cmpd="sng" algn="ctr">
                       <a:solidFill>
                         <a:srgbClr val="DDD5C1"/>
@@ -8238,12 +8238,12 @@
                     <a:p>
                       <a:pPr algn="l" indent="0" marL="0">
                         <a:lnSpc>
-                          <a:spcPts val="2880"/>
+                          <a:spcPts val="3060"/>
                         </a:lnSpc>
                         <a:buNone/>
                       </a:pPr>
                       <a:r>
-                        <a:rPr lang="en-US" sz="2400" dirty="0" spc="-24" kern="0">
+                        <a:rPr lang="en-US" sz="2550" dirty="0" spc="-23" kern="0">
                           <a:solidFill>
                             <a:srgbClr val="14161C"/>
                           </a:solidFill>
@@ -8254,7 +8254,7 @@
                         <a:t>Runtime</a:t>
                       </a:r>
                       <a:r>
-                        <a:rPr lang="en-US" sz="2400" dirty="0" spc="4" kern="0">
+                        <a:rPr lang="en-US" sz="2550" dirty="0" spc="-1" kern="0">
                           <a:solidFill>
                             <a:srgbClr val="14161C"/>
                           </a:solidFill>
@@ -8265,7 +8265,7 @@
                         <a:t> do</a:t>
                       </a:r>
                       <a:r>
-                        <a:rPr lang="en-US" sz="2400" dirty="0" spc="-13" kern="0">
+                        <a:rPr lang="en-US" sz="2550" dirty="0" spc="-16" kern="0">
                           <a:solidFill>
                             <a:srgbClr val="14161C"/>
                           </a:solidFill>
@@ -8276,7 +8276,7 @@
                         <a:t> Lambda</a:t>
                       </a:r>
                       <a:r>
-                        <a:rPr lang="en-US" sz="2400" dirty="0" spc="1" kern="0">
+                        <a:rPr lang="en-US" sz="2550" dirty="0" spc="1" kern="0">
                           <a:solidFill>
                             <a:srgbClr val="14161C"/>
                           </a:solidFill>
@@ -8287,7 +8287,7 @@
                         <a:t> quản</a:t>
                       </a:r>
                       <a:r>
-                        <a:rPr lang="en-US" sz="2400" dirty="0" spc="0" kern="0">
+                        <a:rPr lang="en-US" sz="2550" dirty="0" spc="-1" kern="0">
                           <a:solidFill>
                             <a:srgbClr val="14161C"/>
                           </a:solidFill>
@@ -8295,10 +8295,21 @@
                           <a:ea typeface="Be Vietnam Pro" pitchFamily="34" charset="-122"/>
                           <a:cs typeface="Be Vietnam Pro" pitchFamily="34" charset="-120"/>
                         </a:rPr>
-                        <a:t> lý, chế</a:t>
+                        <a:t> lý,</a:t>
                       </a:r>
                       <a:r>
-                        <a:rPr lang="en-US" sz="2400" dirty="0" spc="17" kern="0">
+                        <a:rPr lang="en-US" sz="2550" dirty="0" spc="1" kern="0">
+                          <a:solidFill>
+                            <a:srgbClr val="14161C"/>
+                          </a:solidFill>
+                          <a:latin typeface="Be Vietnam Pro" pitchFamily="34" charset="0"/>
+                          <a:ea typeface="Be Vietnam Pro" pitchFamily="34" charset="-122"/>
+                          <a:cs typeface="Be Vietnam Pro" pitchFamily="34" charset="-120"/>
+                        </a:rPr>
+                        <a:t> chế</a:t>
+                      </a:r>
+                      <a:r>
+                        <a:rPr lang="en-US" sz="2550" dirty="0" spc="17" kern="0">
                           <a:solidFill>
                             <a:srgbClr val="14161C"/>
                           </a:solidFill>
@@ -8309,7 +8320,7 @@
                         <a:t> độ</a:t>
                       </a:r>
                       <a:r>
-                        <a:rPr lang="en-US" sz="2400" dirty="0" spc="-18" kern="0">
+                        <a:rPr lang="en-US" sz="2550" dirty="0" spc="-19" kern="0">
                           <a:solidFill>
                             <a:srgbClr val="14161C"/>
                           </a:solidFill>
@@ -8322,7 +8333,7 @@
                       <a:endParaRPr lang="en-US" sz="1200" dirty="0"/>
                     </a:p>
                   </a:txBody>
-                  <a:tcPr marL="266700" marR="266700" marT="266700" marB="266700" anchor="ctr">
+                  <a:tcPr marL="228600" marR="228600" marT="228600" marB="228600" anchor="ctr">
                     <a:lnL w="0" cap="flat" cmpd="sng" algn="ctr">
                       <a:noFill/>
                     </a:lnL>
@@ -8353,12 +8364,12 @@
                     <a:p>
                       <a:pPr algn="l" indent="0" marL="0">
                         <a:lnSpc>
-                          <a:spcPts val="2880"/>
+                          <a:spcPts val="3060"/>
                         </a:lnSpc>
                         <a:buNone/>
                       </a:pPr>
                       <a:r>
-                        <a:rPr lang="en-US" sz="2400" dirty="0" spc="-16" kern="0">
+                        <a:rPr lang="en-US" sz="2550" dirty="0" spc="-18" kern="0">
                           <a:solidFill>
                             <a:srgbClr val="14161C"/>
                           </a:solidFill>
@@ -8369,7 +8380,7 @@
                         <a:t>Lambda</a:t>
                       </a:r>
                       <a:r>
-                        <a:rPr lang="en-US" sz="2400" dirty="0" spc="4" kern="0">
+                        <a:rPr lang="en-US" sz="2550" dirty="0" spc="-1" kern="0">
                           <a:solidFill>
                             <a:srgbClr val="14161C"/>
                           </a:solidFill>
@@ -8380,7 +8391,7 @@
                         <a:t> tự</a:t>
                       </a:r>
                       <a:r>
-                        <a:rPr lang="en-US" sz="2400" dirty="0" spc="3" kern="0">
+                        <a:rPr lang="en-US" sz="2550" dirty="0" spc="0" kern="0">
                           <a:solidFill>
                             <a:srgbClr val="14161C"/>
                           </a:solidFill>
@@ -8388,12 +8399,23 @@
                           <a:ea typeface="Be Vietnam Pro" pitchFamily="34" charset="-122"/>
                           <a:cs typeface="Be Vietnam Pro" pitchFamily="34" charset="-120"/>
                         </a:rPr>
-                        <a:t> áp dụng</a:t>
+                        <a:t> áp</a:t>
+                      </a:r>
+                      <a:r>
+                        <a:rPr lang="en-US" sz="2550" dirty="0" spc="-1" kern="0">
+                          <a:solidFill>
+                            <a:srgbClr val="14161C"/>
+                          </a:solidFill>
+                          <a:latin typeface="Be Vietnam Pro" pitchFamily="34" charset="0"/>
+                          <a:ea typeface="Be Vietnam Pro" pitchFamily="34" charset="-122"/>
+                          <a:cs typeface="Be Vietnam Pro" pitchFamily="34" charset="-120"/>
+                        </a:rPr>
+                        <a:t> dụng</a:t>
                       </a:r>
                       <a:endParaRPr lang="en-US" sz="1200" dirty="0"/>
                     </a:p>
                   </a:txBody>
-                  <a:tcPr marL="266700" marR="266700" marT="266700" marB="266700" anchor="ctr">
+                  <a:tcPr marL="228600" marR="228600" marT="228600" marB="228600" anchor="ctr">
                     <a:lnL w="19050" cap="flat" cmpd="sng" algn="ctr">
                       <a:solidFill>
                         <a:srgbClr val="DDD5C1"/>
@@ -8432,12 +8454,12 @@
                     <a:p>
                       <a:pPr algn="l" indent="0" marL="0">
                         <a:lnSpc>
-                          <a:spcPts val="2880"/>
+                          <a:spcPts val="3060"/>
                         </a:lnSpc>
                         <a:buNone/>
                       </a:pPr>
                       <a:r>
-                        <a:rPr lang="en-US" sz="2400" dirty="0" spc="-1" kern="0">
+                        <a:rPr lang="en-US" sz="2550" dirty="0" spc="1" kern="0">
                           <a:solidFill>
                             <a:srgbClr val="14161C"/>
                           </a:solidFill>
@@ -8448,7 +8470,7 @@
                         <a:t>Chế</a:t>
                       </a:r>
                       <a:r>
-                        <a:rPr lang="en-US" sz="2400" dirty="0" spc="17" kern="0">
+                        <a:rPr lang="en-US" sz="2550" dirty="0" spc="17" kern="0">
                           <a:solidFill>
                             <a:srgbClr val="14161C"/>
                           </a:solidFill>
@@ -8459,7 +8481,7 @@
                         <a:t> độ</a:t>
                       </a:r>
                       <a:r>
-                        <a:rPr lang="en-US" sz="2400" dirty="0" spc="-1" kern="0">
+                        <a:rPr lang="en-US" sz="2550" dirty="0" spc="1" kern="0">
                           <a:solidFill>
                             <a:srgbClr val="14161C"/>
                           </a:solidFill>
@@ -8470,7 +8492,7 @@
                         <a:t> Function</a:t>
                       </a:r>
                       <a:r>
-                        <a:rPr lang="en-US" sz="2400" dirty="0" spc="-14" kern="0">
+                        <a:rPr lang="en-US" sz="2550" dirty="0" spc="-15" kern="0">
                           <a:solidFill>
                             <a:srgbClr val="14161C"/>
                           </a:solidFill>
@@ -8481,7 +8503,7 @@
                         <a:t> update</a:t>
                       </a:r>
                       <a:r>
-                        <a:rPr lang="en-US" sz="2400" dirty="0" spc="-2" kern="0">
+                        <a:rPr lang="en-US" sz="2550" dirty="0" spc="-3" kern="0">
                           <a:solidFill>
                             <a:srgbClr val="14161C"/>
                           </a:solidFill>
@@ -8492,7 +8514,7 @@
                         <a:t> hoặc</a:t>
                       </a:r>
                       <a:r>
-                        <a:rPr lang="en-US" sz="2400" dirty="0" spc="1" kern="0">
+                        <a:rPr lang="en-US" sz="2550" dirty="0" spc="1" kern="0">
                           <a:solidFill>
                             <a:srgbClr val="14161C"/>
                           </a:solidFill>
@@ -8505,7 +8527,7 @@
                       <a:endParaRPr lang="en-US" sz="1200" dirty="0"/>
                     </a:p>
                   </a:txBody>
-                  <a:tcPr marL="266700" marR="266700" marT="266700" marB="266700" anchor="ctr">
+                  <a:tcPr marL="228600" marR="228600" marT="228600" marB="228600" anchor="ctr">
                     <a:lnL w="0" cap="flat" cmpd="sng" algn="ctr">
                       <a:noFill/>
                     </a:lnL>
@@ -8536,12 +8558,12 @@
                     <a:p>
                       <a:pPr algn="l" indent="0" marL="0">
                         <a:lnSpc>
-                          <a:spcPts val="2880"/>
+                          <a:spcPts val="3060"/>
                         </a:lnSpc>
                         <a:buNone/>
                       </a:pPr>
                       <a:r>
-                        <a:rPr lang="en-US" sz="2400" dirty="0" spc="3" kern="0">
+                        <a:rPr lang="en-US" sz="2550" dirty="0" spc="2" kern="0">
                           <a:solidFill>
                             <a:srgbClr val="14161C"/>
                           </a:solidFill>
@@ -8552,7 +8574,7 @@
                         <a:t>Bạn</a:t>
                       </a:r>
                       <a:r>
-                        <a:rPr lang="en-US" sz="2400" dirty="0" spc="2" kern="0">
+                        <a:rPr lang="en-US" sz="2550" dirty="0" spc="1" kern="0">
                           <a:solidFill>
                             <a:srgbClr val="14161C"/>
                           </a:solidFill>
@@ -8563,7 +8585,7 @@
                         <a:t> cập</a:t>
                       </a:r>
                       <a:r>
-                        <a:rPr lang="en-US" sz="2400" dirty="0" spc="-8" kern="0">
+                        <a:rPr lang="en-US" sz="2550" dirty="0" spc="-10" kern="0">
                           <a:solidFill>
                             <a:srgbClr val="14161C"/>
                           </a:solidFill>
@@ -8574,7 +8596,7 @@
                         <a:t> nhật</a:t>
                       </a:r>
                       <a:r>
-                        <a:rPr lang="en-US" sz="2400" dirty="0" spc="3" kern="0">
+                        <a:rPr lang="en-US" sz="2550" dirty="0" spc="1" kern="0">
                           <a:solidFill>
                             <a:srgbClr val="14161C"/>
                           </a:solidFill>
@@ -8585,7 +8607,7 @@
                         <a:t> hàm</a:t>
                       </a:r>
                       <a:r>
-                        <a:rPr lang="en-US" sz="2400" dirty="0" spc="-2" kern="0">
+                        <a:rPr lang="en-US" sz="2550" dirty="0" spc="-2" kern="0">
                           <a:solidFill>
                             <a:srgbClr val="14161C"/>
                           </a:solidFill>
@@ -8596,7 +8618,7 @@
                         <a:t> hoặc</a:t>
                       </a:r>
                       <a:r>
-                        <a:rPr lang="en-US" sz="2400" dirty="0" spc="0" kern="0">
+                        <a:rPr lang="en-US" sz="2550" dirty="0" spc="-1" kern="0">
                           <a:solidFill>
                             <a:srgbClr val="14161C"/>
                           </a:solidFill>
@@ -8604,10 +8626,21 @@
                           <a:ea typeface="Be Vietnam Pro" pitchFamily="34" charset="-122"/>
                           <a:cs typeface="Be Vietnam Pro" pitchFamily="34" charset="-120"/>
                         </a:rPr>
-                        <a:t> chọn phiên</a:t>
+                        <a:t> chọn</a:t>
                       </a:r>
                       <a:r>
-                        <a:rPr lang="en-US" sz="2400" dirty="0" spc="-1" kern="0">
+                        <a:rPr lang="en-US" sz="2550" dirty="0" spc="0" kern="0">
+                          <a:solidFill>
+                            <a:srgbClr val="14161C"/>
+                          </a:solidFill>
+                          <a:latin typeface="Be Vietnam Pro" pitchFamily="34" charset="0"/>
+                          <a:ea typeface="Be Vietnam Pro" pitchFamily="34" charset="-122"/>
+                          <a:cs typeface="Be Vietnam Pro" pitchFamily="34" charset="-120"/>
+                        </a:rPr>
+                        <a:t> phiên</a:t>
+                      </a:r>
+                      <a:r>
+                        <a:rPr lang="en-US" sz="2550" dirty="0" spc="-3" kern="0">
                           <a:solidFill>
                             <a:srgbClr val="14161C"/>
                           </a:solidFill>
@@ -8620,7 +8653,7 @@
                       <a:endParaRPr lang="en-US" sz="1200" dirty="0"/>
                     </a:p>
                   </a:txBody>
-                  <a:tcPr marL="266700" marR="266700" marT="266700" marB="266700" anchor="ctr">
+                  <a:tcPr marL="228600" marR="228600" marT="228600" marB="228600" anchor="ctr">
                     <a:lnL w="19050" cap="flat" cmpd="sng" algn="ctr">
                       <a:solidFill>
                         <a:srgbClr val="DDD5C1"/>
@@ -8659,12 +8692,12 @@
                     <a:p>
                       <a:pPr algn="l" indent="0" marL="0">
                         <a:lnSpc>
-                          <a:spcPts val="2880"/>
+                          <a:spcPts val="3060"/>
                         </a:lnSpc>
                         <a:buNone/>
                       </a:pPr>
                       <a:r>
-                        <a:rPr lang="en-US" sz="2400" dirty="0" spc="-24" kern="0">
+                        <a:rPr lang="en-US" sz="2550" dirty="0" spc="-23" kern="0">
                           <a:solidFill>
                             <a:srgbClr val="14161C"/>
                           </a:solidFill>
@@ -8675,7 +8708,7 @@
                         <a:t>Runtime</a:t>
                       </a:r>
                       <a:r>
-                        <a:rPr lang="en-US" sz="2400" dirty="0" spc="20" kern="0">
+                        <a:rPr lang="en-US" sz="2550" dirty="0" spc="17" kern="0">
                           <a:solidFill>
                             <a:srgbClr val="14161C"/>
                           </a:solidFill>
@@ -8686,7 +8719,7 @@
                         <a:t> đã</a:t>
                       </a:r>
                       <a:r>
-                        <a:rPr lang="en-US" sz="2400" dirty="0" spc="19" kern="0">
+                        <a:rPr lang="en-US" sz="2550" dirty="0" spc="16" kern="0">
                           <a:solidFill>
                             <a:srgbClr val="14161C"/>
                           </a:solidFill>
@@ -8697,7 +8730,7 @@
                         <a:t> ngừng</a:t>
                       </a:r>
                       <a:r>
-                        <a:rPr lang="en-US" sz="2400" dirty="0" spc="2" kern="0">
+                        <a:rPr lang="en-US" sz="2550" dirty="0" spc="0" kern="0">
                           <a:solidFill>
                             <a:srgbClr val="14161C"/>
                           </a:solidFill>
@@ -8708,7 +8741,7 @@
                         <a:t> hỗ</a:t>
                       </a:r>
                       <a:r>
-                        <a:rPr lang="en-US" sz="2400" dirty="0" spc="-22" kern="0">
+                        <a:rPr lang="en-US" sz="2550" dirty="0" spc="-25" kern="0">
                           <a:solidFill>
                             <a:srgbClr val="14161C"/>
                           </a:solidFill>
@@ -8721,7 +8754,7 @@
                       <a:endParaRPr lang="en-US" sz="1200" dirty="0"/>
                     </a:p>
                   </a:txBody>
-                  <a:tcPr marL="266700" marR="266700" marT="266700" marB="266700" anchor="ctr">
+                  <a:tcPr marL="228600" marR="228600" marT="228600" marB="228600" anchor="ctr">
                     <a:lnL w="0" cap="flat" cmpd="sng" algn="ctr">
                       <a:noFill/>
                     </a:lnL>
@@ -8752,12 +8785,12 @@
                     <a:p>
                       <a:pPr algn="l" indent="0" marL="0">
                         <a:lnSpc>
-                          <a:spcPts val="2880"/>
+                          <a:spcPts val="3060"/>
                         </a:lnSpc>
                         <a:buNone/>
                       </a:pPr>
                       <a:r>
-                        <a:rPr lang="en-US" sz="2400" dirty="0" spc="28" kern="0">
+                        <a:rPr lang="en-US" sz="2550" dirty="0" spc="24" kern="0">
                           <a:solidFill>
                             <a:srgbClr val="14161C"/>
                           </a:solidFill>
@@ -8768,7 +8801,7 @@
                         <a:t>Đừng</a:t>
                       </a:r>
                       <a:r>
-                        <a:rPr lang="en-US" sz="2400" dirty="0" spc="0" kern="0">
+                        <a:rPr lang="en-US" sz="2550" dirty="0" spc="-1" kern="0">
                           <a:solidFill>
                             <a:srgbClr val="14161C"/>
                           </a:solidFill>
@@ -8779,7 +8812,7 @@
                         <a:t> chờ</a:t>
                       </a:r>
                       <a:r>
-                        <a:rPr lang="en-US" sz="2400" dirty="0" spc="-12" kern="0">
+                        <a:rPr lang="en-US" sz="2550" dirty="0" spc="-13" kern="0">
                           <a:solidFill>
                             <a:srgbClr val="14161C"/>
                           </a:solidFill>
@@ -8790,7 +8823,7 @@
                         <a:t> vá:</a:t>
                       </a:r>
                       <a:r>
-                        <a:rPr lang="en-US" sz="2400" dirty="0" spc="-13" kern="0">
+                        <a:rPr lang="en-US" sz="2550" dirty="0" spc="-12" kern="0">
                           <a:solidFill>
                             <a:srgbClr val="14161C"/>
                           </a:solidFill>
@@ -8801,7 +8834,7 @@
                         <a:t> chuyển</a:t>
                       </a:r>
                       <a:r>
-                        <a:rPr lang="en-US" sz="2400" dirty="0" spc="-5" kern="0">
+                        <a:rPr lang="en-US" sz="2550" dirty="0" spc="-5" kern="0">
                           <a:solidFill>
                             <a:srgbClr val="14161C"/>
                           </a:solidFill>
@@ -8812,7 +8845,7 @@
                         <a:t> runtime</a:t>
                       </a:r>
                       <a:r>
-                        <a:rPr lang="en-US" sz="2400" dirty="0" spc="-1" kern="0">
+                        <a:rPr lang="en-US" sz="2550" dirty="0" spc="0" kern="0">
                           <a:solidFill>
                             <a:srgbClr val="14161C"/>
                           </a:solidFill>
@@ -8823,7 +8856,7 @@
                         <a:t> còn</a:t>
                       </a:r>
                       <a:r>
-                        <a:rPr lang="en-US" sz="2400" dirty="0" spc="1" kern="0">
+                        <a:rPr lang="en-US" sz="2550" dirty="0" spc="-1" kern="0">
                           <a:solidFill>
                             <a:srgbClr val="14161C"/>
                           </a:solidFill>
@@ -8834,7 +8867,7 @@
                         <a:t> hỗ</a:t>
                       </a:r>
                       <a:r>
-                        <a:rPr lang="en-US" sz="2400" dirty="0" spc="-21" kern="0">
+                        <a:rPr lang="en-US" sz="2550" dirty="0" spc="-25" kern="0">
                           <a:solidFill>
                             <a:srgbClr val="14161C"/>
                           </a:solidFill>
@@ -8847,7 +8880,7 @@
                       <a:endParaRPr lang="en-US" sz="1200" dirty="0"/>
                     </a:p>
                   </a:txBody>
-                  <a:tcPr marL="266700" marR="266700" marT="266700" marB="266700" anchor="ctr">
+                  <a:tcPr marL="228600" marR="228600" marT="228600" marB="228600" anchor="ctr">
                     <a:lnL w="19050" cap="flat" cmpd="sng" algn="ctr">
                       <a:solidFill>
                         <a:srgbClr val="DDD5C1"/>

</xml_diff>